<commit_message>
Refresh lecture decks from updated AA174A/AA203 sources
Regenerated all 37 PPTX decks from the current OneDrive originals.
Media is recompressed in place (H.264 video, deflate TIFF, downscaled
PNG/JPEG/GIF) with filenames and extensions preserved, so package
relationships stay intact; every deck verifies at exact slide, shape and
media-count parity with its source.

1.7 GB of source decks -> 345 MB, no file above GitHub's 100 MB limit.

Co-Authored-By: Claude Opus 5 (1M context) <noreply@anthropic.com>
</commit_message>
<xml_diff>
--- a/public/slides/aa174a/lecture_2.pptx
+++ b/public/slides/aa174a/lecture_2.pptx
@@ -125,9 +125,6 @@
             <p14:sldId id="258"/>
           </p14:sldIdLst>
         </p14:section>
-        <p14:section name="Intro to ROS" id="{90210F2D-5795-054C-9836-CDD4575C5B23}">
-          <p14:sldIdLst/>
-        </p14:section>
       </p14:sectionLst>
     </p:ext>
     <p:ext uri="{EFAFB233-063F-42B5-8137-9DF3F51BA10A}">
@@ -137,17 +134,18 @@
 </p:presentation>
 </file>
 
-<file path=ppt/revisionInfo.xml><?xml version="1.0" encoding="utf-8"?>
-<p1510:revInfo xmlns:a="http://schemas.openxmlformats.org/drawingml/2006/main" xmlns:r="http://schemas.openxmlformats.org/officeDocument/2006/relationships" xmlns:p1510="http://schemas.microsoft.com/office/powerpoint/2015/10/main">
-  <p1510:revLst>
-    <p1510:client id="{3286D8FC-1BD2-9DC5-6020-25E6BA66F1CB}" v="9" dt="2025-09-24T21:43:05.358"/>
-    <p1510:client id="{3F0070FA-8D8F-B847-A38D-8B9C5E36621C}" v="537" dt="2025-09-24T19:00:38.669"/>
-    <p1510:client id="{75AE4330-5A60-A9F3-C227-E999B313E7E6}" v="2" dt="2025-09-23T18:39:17.905"/>
-    <p1510:client id="{9AD9F6B0-8709-E442-9B18-6FB1A0B7624B}" v="1" dt="2025-12-31T07:24:24.240"/>
-    <p1510:client id="{9BAB4F35-FFE2-6842-82EE-FFEDB7B17CA4}" v="2" dt="2025-09-23T18:43:17.346"/>
-    <p1510:client id="{A0310FBB-A33B-A0A4-BB4A-2539035BC273}" v="22" dt="2025-09-25T17:29:59.297"/>
-  </p1510:revLst>
-</p1510:revInfo>
+<file path=ppt/changesInfos/changesInfo1.xml><?xml version="1.0" encoding="utf-8"?>
+<pc:chgInfo xmlns:a="http://schemas.openxmlformats.org/drawingml/2006/main" xmlns:r="http://schemas.openxmlformats.org/officeDocument/2006/relationships" xmlns:ac="http://schemas.microsoft.com/office/drawing/2013/main/command" xmlns:pc="http://schemas.microsoft.com/office/powerpoint/2013/main/command">
+  <pc:docChgLst>
+    <pc:chgData name="Daniele Gammelli" userId="292b8a31-f1ba-4b4c-b196-a231dc095d13" providerId="ADAL" clId="{6E670754-AB6A-5789-AA0A-6F6FD9CE3EEA}"/>
+    <pc:docChg chg="delSection modSection">
+      <pc:chgData name="Daniele Gammelli" userId="292b8a31-f1ba-4b4c-b196-a231dc095d13" providerId="ADAL" clId="{6E670754-AB6A-5789-AA0A-6F6FD9CE3EEA}" dt="2026-08-13T22:44:08.902" v="1" actId="17851"/>
+      <pc:docMkLst>
+        <pc:docMk/>
+      </pc:docMkLst>
+    </pc:docChg>
+  </pc:docChgLst>
+</pc:chgInfo>
 </file>
 
 <file path=ppt/notesMasters/notesMaster1.xml><?xml version="1.0" encoding="utf-8"?>
@@ -232,7 +230,7 @@
           <a:p>
             <a:fld id="{EBD6F028-2067-3740-AA48-A91E93570B1D}" type="datetimeFigureOut">
               <a:rPr lang="en-US" smtClean="0"/>
-              <a:t>12/30/25</a:t>
+              <a:t>8/13/26</a:t>
             </a:fld>
             <a:endParaRPr lang="en-US"/>
           </a:p>
@@ -583,6 +581,90 @@
 </p:notes>
 </file>
 
+<file path=ppt/notesSlides/notesSlide2.xml><?xml version="1.0" encoding="utf-8"?>
+<p:notes xmlns:a="http://schemas.openxmlformats.org/drawingml/2006/main" xmlns:r="http://schemas.openxmlformats.org/officeDocument/2006/relationships" xmlns:p="http://schemas.openxmlformats.org/presentationml/2006/main">
+  <p:cSld>
+    <p:spTree>
+      <p:nvGrpSpPr>
+        <p:cNvPr id="1" name=""/>
+        <p:cNvGrpSpPr/>
+        <p:nvPr/>
+      </p:nvGrpSpPr>
+      <p:grpSpPr>
+        <a:xfrm>
+          <a:off x="0" y="0"/>
+          <a:ext cx="0" cy="0"/>
+          <a:chOff x="0" y="0"/>
+          <a:chExt cx="0" cy="0"/>
+        </a:xfrm>
+      </p:grpSpPr>
+      <p:sp>
+        <p:nvSpPr>
+          <p:cNvPr id="2" name="Slide Image Placeholder 1"/>
+          <p:cNvSpPr>
+            <a:spLocks noGrp="1" noRot="1" noChangeAspect="1"/>
+          </p:cNvSpPr>
+          <p:nvPr>
+            <p:ph type="sldImg"/>
+          </p:nvPr>
+        </p:nvSpPr>
+        <p:spPr/>
+      </p:sp>
+      <p:sp>
+        <p:nvSpPr>
+          <p:cNvPr id="3" name="Notes Placeholder 2"/>
+          <p:cNvSpPr>
+            <a:spLocks noGrp="1"/>
+          </p:cNvSpPr>
+          <p:nvPr>
+            <p:ph type="body" idx="1"/>
+          </p:nvPr>
+        </p:nvSpPr>
+        <p:spPr/>
+        <p:txBody>
+          <a:bodyPr/>
+          <a:lstStyle/>
+          <a:p>
+            <a:endParaRPr lang="en-US" dirty="0"/>
+          </a:p>
+        </p:txBody>
+      </p:sp>
+      <p:sp>
+        <p:nvSpPr>
+          <p:cNvPr id="4" name="Slide Number Placeholder 3"/>
+          <p:cNvSpPr>
+            <a:spLocks noGrp="1"/>
+          </p:cNvSpPr>
+          <p:nvPr>
+            <p:ph type="sldNum" sz="quarter" idx="5"/>
+          </p:nvPr>
+        </p:nvSpPr>
+        <p:spPr/>
+        <p:txBody>
+          <a:bodyPr/>
+          <a:lstStyle/>
+          <a:p>
+            <a:fld id="{63B2D7EC-928D-0645-AAE8-498D7443D60E}" type="slidenum">
+              <a:rPr lang="en-US" smtClean="0"/>
+              <a:t>2</a:t>
+            </a:fld>
+            <a:endParaRPr lang="en-US"/>
+          </a:p>
+        </p:txBody>
+      </p:sp>
+    </p:spTree>
+    <p:extLst>
+      <p:ext uri="{BB962C8B-B14F-4D97-AF65-F5344CB8AC3E}">
+        <p14:creationId xmlns:p14="http://schemas.microsoft.com/office/powerpoint/2010/main" val="3178998201"/>
+      </p:ext>
+    </p:extLst>
+  </p:cSld>
+  <p:clrMapOvr>
+    <a:masterClrMapping/>
+  </p:clrMapOvr>
+</p:notes>
+</file>
+
 <file path=ppt/slideLayouts/slideLayout1.xml><?xml version="1.0" encoding="utf-8"?>
 <p:sldLayout xmlns:a="http://schemas.openxmlformats.org/drawingml/2006/main" xmlns:r="http://schemas.openxmlformats.org/officeDocument/2006/relationships" xmlns:p="http://schemas.openxmlformats.org/presentationml/2006/main" type="title" preserve="1">
   <p:cSld name="Title Slide">
@@ -712,7 +794,7 @@
           <a:p>
             <a:fld id="{B41BB99C-E95E-454A-8541-52414DF53202}" type="datetime1">
               <a:rPr lang="en-US" smtClean="0"/>
-              <a:t>12/30/25</a:t>
+              <a:t>8/13/26</a:t>
             </a:fld>
             <a:endParaRPr lang="en-US"/>
           </a:p>
@@ -930,7 +1012,7 @@
           <a:p>
             <a:fld id="{C279CCE3-8735-FC45-92E1-19E3A31721CA}" type="datetime1">
               <a:rPr lang="en-US" smtClean="0"/>
-              <a:t>12/30/25</a:t>
+              <a:t>8/13/26</a:t>
             </a:fld>
             <a:endParaRPr lang="en-US"/>
           </a:p>
@@ -1112,7 +1194,7 @@
           <a:p>
             <a:fld id="{075116F0-A659-7746-8280-EEE86BB876DC}" type="datetime1">
               <a:rPr lang="en-US" smtClean="0"/>
-              <a:t>12/30/25</a:t>
+              <a:t>8/13/26</a:t>
             </a:fld>
             <a:endParaRPr lang="en-US"/>
           </a:p>
@@ -1367,7 +1449,7 @@
           <a:p>
             <a:fld id="{EEC17845-F457-3345-97FE-653DDEF23DB5}" type="datetime1">
               <a:rPr lang="en-US" smtClean="0"/>
-              <a:t>12/30/25</a:t>
+              <a:t>8/13/26</a:t>
             </a:fld>
             <a:endParaRPr lang="en-US"/>
           </a:p>
@@ -1628,7 +1710,7 @@
           <a:p>
             <a:fld id="{B763C39D-04F2-A44B-81D9-688ACBCAD9D2}" type="datetime1">
               <a:rPr lang="en-US" smtClean="0"/>
-              <a:t>12/30/25</a:t>
+              <a:t>8/13/26</a:t>
             </a:fld>
             <a:endParaRPr lang="en-US"/>
           </a:p>
@@ -1861,7 +1943,7 @@
           <a:p>
             <a:fld id="{9820A91A-8E5F-B74F-8313-EF670DA0E825}" type="datetime1">
               <a:rPr lang="en-US" smtClean="0"/>
-              <a:t>12/30/25</a:t>
+              <a:t>8/13/26</a:t>
             </a:fld>
             <a:endParaRPr lang="en-US"/>
           </a:p>
@@ -2229,7 +2311,7 @@
           <a:p>
             <a:fld id="{0DB35A3A-EFBA-4D40-8B3A-5C4CAA35F93E}" type="datetime1">
               <a:rPr lang="en-US" smtClean="0"/>
-              <a:t>12/30/25</a:t>
+              <a:t>8/13/26</a:t>
             </a:fld>
             <a:endParaRPr lang="en-US"/>
           </a:p>
@@ -2350,7 +2432,7 @@
           <a:p>
             <a:fld id="{45DF4D13-3D15-244A-B9FD-70C2C5801865}" type="datetime1">
               <a:rPr lang="en-US" smtClean="0"/>
-              <a:t>12/30/25</a:t>
+              <a:t>8/13/26</a:t>
             </a:fld>
             <a:endParaRPr lang="en-US"/>
           </a:p>
@@ -2449,7 +2531,7 @@
           <a:p>
             <a:fld id="{358677E7-6069-684B-88B5-61A49AF68C26}" type="datetime1">
               <a:rPr lang="en-US" smtClean="0"/>
-              <a:t>12/30/25</a:t>
+              <a:t>8/13/26</a:t>
             </a:fld>
             <a:endParaRPr lang="en-US"/>
           </a:p>
@@ -2728,7 +2810,7 @@
           <a:p>
             <a:fld id="{AF4FED95-28B2-D544-9611-16E3E1B838E8}" type="datetime1">
               <a:rPr lang="en-US" smtClean="0"/>
-              <a:t>12/30/25</a:t>
+              <a:t>8/13/26</a:t>
             </a:fld>
             <a:endParaRPr lang="en-US"/>
           </a:p>
@@ -2984,7 +3066,7 @@
           <a:p>
             <a:fld id="{F5DE12A8-3A47-C748-B1B9-7FCAA212294C}" type="datetime1">
               <a:rPr lang="en-US" smtClean="0"/>
-              <a:t>12/30/25</a:t>
+              <a:t>8/13/26</a:t>
             </a:fld>
             <a:endParaRPr lang="en-US"/>
           </a:p>
@@ -3199,7 +3281,7 @@
           <a:p>
             <a:fld id="{EF3D8782-EF8F-824A-8811-89A4DCC0497B}" type="datetime1">
               <a:rPr lang="en-US" smtClean="0"/>
-              <a:t>12/30/25</a:t>
+              <a:t>8/13/26</a:t>
             </a:fld>
             <a:endParaRPr lang="en-US"/>
           </a:p>
@@ -3775,7 +3857,7 @@
           </p:nvPr>
         </p:nvPicPr>
         <p:blipFill>
-          <a:blip r:embed="rId2"/>
+          <a:blip r:embed="rId3"/>
           <a:stretch>
             <a:fillRect/>
           </a:stretch>

</xml_diff>